<commit_message>
research: expand group meeting speaker notes
</commit_message>
<xml_diff>
--- a/reports/22_五仓库指令遵从性研究组会汇报_白底黑字版.pptx
+++ b/reports/22_五仓库指令遵从性研究组会汇报_白底黑字版.pptx
@@ -2,24 +2,24 @@
 <file path=ppt/presentation.xml><?xml version="1.0" encoding="utf-8"?>
 <p:presentation xmlns:p="http://schemas.openxmlformats.org/presentationml/2006/main">
   <p:sldMasterIdLst>
-    <p:sldMasterId xmlns:r="http://schemas.openxmlformats.org/officeDocument/2006/relationships" id="2147483648" r:id="R62f8a57b3f484016"/>
+    <p:sldMasterId xmlns:r="http://schemas.openxmlformats.org/officeDocument/2006/relationships" id="2147483648" r:id="R53dc27ca370245c9"/>
   </p:sldMasterIdLst>
   <p:notesMasterIdLst>
-    <p:notesMasterId xmlns:r="http://schemas.openxmlformats.org/officeDocument/2006/relationships" r:id="R0311f0caec1d4ff1"/>
+    <p:notesMasterId xmlns:r="http://schemas.openxmlformats.org/officeDocument/2006/relationships" r:id="R2ef01974991243be"/>
   </p:notesMasterIdLst>
   <p:sldIdLst>
-    <p:sldId xmlns:r="http://schemas.openxmlformats.org/officeDocument/2006/relationships" id="256" r:id="R0006086b58a84398"/>
-    <p:sldId xmlns:r="http://schemas.openxmlformats.org/officeDocument/2006/relationships" id="257" r:id="R5aa29996d08e4e95"/>
-    <p:sldId xmlns:r="http://schemas.openxmlformats.org/officeDocument/2006/relationships" id="258" r:id="R51dc3841d4604c3f"/>
-    <p:sldId xmlns:r="http://schemas.openxmlformats.org/officeDocument/2006/relationships" id="259" r:id="R4d2b86e694d44f7b"/>
-    <p:sldId xmlns:r="http://schemas.openxmlformats.org/officeDocument/2006/relationships" id="260" r:id="Raa297db7fc404081"/>
-    <p:sldId xmlns:r="http://schemas.openxmlformats.org/officeDocument/2006/relationships" id="261" r:id="R946851da19f54327"/>
-    <p:sldId xmlns:r="http://schemas.openxmlformats.org/officeDocument/2006/relationships" id="262" r:id="R68f9c951bc1a4d89"/>
-    <p:sldId xmlns:r="http://schemas.openxmlformats.org/officeDocument/2006/relationships" id="263" r:id="Rae18c0d33f3746c7"/>
-    <p:sldId xmlns:r="http://schemas.openxmlformats.org/officeDocument/2006/relationships" id="264" r:id="R4fee48de166b4ea1"/>
-    <p:sldId xmlns:r="http://schemas.openxmlformats.org/officeDocument/2006/relationships" id="265" r:id="R8dca576de50449ab"/>
-    <p:sldId xmlns:r="http://schemas.openxmlformats.org/officeDocument/2006/relationships" id="266" r:id="Rcad0a88f94b04e74"/>
-    <p:sldId xmlns:r="http://schemas.openxmlformats.org/officeDocument/2006/relationships" id="267" r:id="Ree53b70db1414062"/>
+    <p:sldId xmlns:r="http://schemas.openxmlformats.org/officeDocument/2006/relationships" id="256" r:id="Ra029107676174ab8"/>
+    <p:sldId xmlns:r="http://schemas.openxmlformats.org/officeDocument/2006/relationships" id="257" r:id="R5185cbd54fb54818"/>
+    <p:sldId xmlns:r="http://schemas.openxmlformats.org/officeDocument/2006/relationships" id="258" r:id="R2c578053af184b6d"/>
+    <p:sldId xmlns:r="http://schemas.openxmlformats.org/officeDocument/2006/relationships" id="259" r:id="R8dccfe6665224117"/>
+    <p:sldId xmlns:r="http://schemas.openxmlformats.org/officeDocument/2006/relationships" id="260" r:id="Rc65488314d3944c9"/>
+    <p:sldId xmlns:r="http://schemas.openxmlformats.org/officeDocument/2006/relationships" id="261" r:id="R50ee1dc48b67408e"/>
+    <p:sldId xmlns:r="http://schemas.openxmlformats.org/officeDocument/2006/relationships" id="262" r:id="R6f68fed7b4d04d7d"/>
+    <p:sldId xmlns:r="http://schemas.openxmlformats.org/officeDocument/2006/relationships" id="263" r:id="R3745af91ec5c4007"/>
+    <p:sldId xmlns:r="http://schemas.openxmlformats.org/officeDocument/2006/relationships" id="264" r:id="Rac44a8d205e040cd"/>
+    <p:sldId xmlns:r="http://schemas.openxmlformats.org/officeDocument/2006/relationships" id="265" r:id="Rfb18e73564794d54"/>
+    <p:sldId xmlns:r="http://schemas.openxmlformats.org/officeDocument/2006/relationships" id="266" r:id="R6ab7cedd1599453d"/>
+    <p:sldId xmlns:r="http://schemas.openxmlformats.org/officeDocument/2006/relationships" id="267" r:id="Rb96d8f6320d2425c"/>
   </p:sldIdLst>
   <p:sldSz cx="12192000" cy="6858000"/>
   <p:notesSz cx="6858000" cy="9144000"/>
@@ -453,7 +453,7 @@
           <a:lstStyle xmlns:a="http://schemas.openxmlformats.org/drawingml/2006/main"/>
           <a:p xmlns:a="http://schemas.openxmlformats.org/drawingml/2006/main">
             <a:r>
-              <a:t>开场先把问题说清楚：我们研究的不是哪个 Agent 框架更强，也不是复述它们的功能列表，而是追问代码层面究竟有哪些机制试图让 Agent 按指令行动。这次覆盖五个仓库、35 个机制，并把关键判断落实到 82 个带路径和行号的代码片段。汇报会集中讲共同结构、局部强制和边界，不展开逐行源码。</a:t>
+              <a:t>【开场定位】这一页先建立研究口径。我们考察 AutoGen、Cline、MetaGPT、OpenHands 和 browser-use 五个开源 Agent 仓库，关心代码如何接收多来源指令、塑造模型可见上下文、限制工具动作，并在失败后停止、恢复或记录。五个仓库都绑定到固定提交，用户给出的热度数字只说明抽样背景，不参与项目排名。</a:t>
             </a:r>
           </a:p>
           <a:p xmlns:a="http://schemas.openxmlformats.org/drawingml/2006/main">
@@ -463,17 +463,52 @@
           </a:p>
           <a:p xmlns:a="http://schemas.openxmlformats.org/drawingml/2006/main">
             <a:r>
+              <a:t>【页面解读】“遵从指令”在本研究中是一条可追踪的控制链：指令进入上下文，模型提出计划或工具调用，参数经过解析与校验，执行器触发文件、终端、浏览器或外部服务，随后系统处理结果与后续状态。本轮最终纳入 35 个机制，并在证据报告中整理出 82 个带路径、行号和上下文的代码片段。后续页面会从生命周期、作用方式、失败语义和旁路四个角度比较这些机制。</a:t>
+            </a:r>
+          </a:p>
+          <a:p xmlns:a="http://schemas.openxmlformats.org/drawingml/2006/main">
+            <a:r>
+              <a:t/>
+            </a:r>
+          </a:p>
+          <a:p xmlns:a="http://schemas.openxmlformats.org/drawingml/2006/main">
+            <a:r>
+              <a:t>【证据边界】静态分析可以确认实现入口、调用顺序、默认值、决定性分支和仓库内测试断言；它不能直接给出真实任务中的模型遵从率，也无法替外部 SDK、provider 或生产服务完成行为验证。E2 仅表示固定提交中存在相应测试断言，本轮没有把未执行的测试写成“测试通过”。</a:t>
+            </a:r>
+          </a:p>
+          <a:p xmlns:a="http://schemas.openxmlformats.org/drawingml/2006/main">
+            <a:r>
+              <a:t/>
+            </a:r>
+          </a:p>
+          <a:p xmlns:a="http://schemas.openxmlformats.org/drawingml/2006/main">
+            <a:r>
+              <a:t>【过渡衔接】下一页把宽泛的“安全”或“遵从”讨论收窄成三个可核验问题：控制覆盖什么、失败时如何处理、证据能支持多强的结论。</a:t>
+            </a:r>
+          </a:p>
+          <a:p xmlns:a="http://schemas.openxmlformats.org/drawingml/2006/main">
+            <a:r>
+              <a:t/>
+            </a:r>
+          </a:p>
+          <a:p xmlns:a="http://schemas.openxmlformats.org/drawingml/2006/main">
+            <a:r>
               <a:t>[Sources]</a:t>
             </a:r>
           </a:p>
           <a:p xmlns:a="http://schemas.openxmlformats.org/drawingml/2006/main">
             <a:r>
-              <a:t>- D:\FDU\科研环节\harness\reports\17_五仓库指令遵从性静态分析计划.md（研究对象与目标）</a:t>
-            </a:r>
-          </a:p>
-          <a:p xmlns:a="http://schemas.openxmlformats.org/drawingml/2006/main">
-            <a:r>
-              <a:t>- D:\FDU\科研环节\harness\reports\20_五仓库指令遵从性逐机制代码片段证据.md（覆盖总表与核验结论）</a:t>
+              <a:t>- reports/17_五仓库指令遵从性静态分析计划.md（研究对象、目标与证据边界）</a:t>
+            </a:r>
+          </a:p>
+          <a:p xmlns:a="http://schemas.openxmlformats.org/drawingml/2006/main">
+            <a:r>
+              <a:t>- reports/18_五仓库指令遵从性静态分析实验记录.md（固定版本与实验范围）</a:t>
+            </a:r>
+          </a:p>
+          <a:p xmlns:a="http://schemas.openxmlformats.org/drawingml/2006/main">
+            <a:r>
+              <a:t>- reports/20_五仓库指令遵从性逐机制代码片段证据.md（覆盖总表与核验结论）</a:t>
             </a:r>
           </a:p>
         </p:txBody>
@@ -543,7 +578,7 @@
           <a:lstStyle xmlns:a="http://schemas.openxmlformats.org/drawingml/2006/main"/>
           <a:p xmlns:a="http://schemas.openxmlformats.org/drawingml/2006/main">
             <a:r>
-              <a:t>20 号报告对 35 个机制逐一补齐代码片段，共形成 82 个代码块，并把实现、裁决或 sink、默认或旁路、测试断言或缺口放在同一处复核。复核后对 19 号报告做了 11 处实质修正，例如 Docker 网络只能说“未显式关闭”，不能说所有部署默认联网；Cline heredoc body 的屏蔽不等于文件重定向全部绕过；provider 分支只能证明本地不执行，不能证明外部动作成功。证据更详细的同时，结论反而更克制。</a:t>
+              <a:t>【开场定位】这一页解释证据复核的颗粒度。我们没有停在机制列表，而是为 35 个机制建立代码证据卡片，共整理 82 个片段，覆盖实现入口、调用者、真实 sink、默认或旁路，以及能确认行为的测试断言。</a:t>
             </a:r>
           </a:p>
           <a:p xmlns:a="http://schemas.openxmlformats.org/drawingml/2006/main">
@@ -553,17 +588,47 @@
           </a:p>
           <a:p xmlns:a="http://schemas.openxmlformats.org/drawingml/2006/main">
             <a:r>
+              <a:t>【页面解读】每张证据卡先给机制 ID 和形式化八元组，再列源码文件、行号、最小必要代码与作用说明。随后检查决定性分支：例如审批拒绝是否真的跳过 executor，路径检查是否在文件写入前发生，URL watchdog 是否能触达浏览器导航，评审结果是否支配保存。第三步补上默认和异常：开关默认值、未命中规则、callback 缺失、解析失败、外部 provider 与降级路径。最后记录测试锚点，明确测试断言到达的是哪条代码路径。报告 20 将代码、判读与边界放在同一处，便于复查和后续动态实验设计。</a:t>
+            </a:r>
+          </a:p>
+          <a:p xmlns:a="http://schemas.openxmlformats.org/drawingml/2006/main">
+            <a:r>
+              <a:t/>
+            </a:r>
+          </a:p>
+          <a:p xmlns:a="http://schemas.openxmlformats.org/drawingml/2006/main">
+            <a:r>
+              <a:t>【证据边界】E1 表示存在可追踪实现，E2 表示仓库中存在对应测试源码；两者都不等同于独立动态复现。行号绑定固定提交，仓库更新后需要重新校准。OpenHands 等外部执行边界无法用当前仓库片段补全。</a:t>
+            </a:r>
+          </a:p>
+          <a:p xmlns:a="http://schemas.openxmlformats.org/drawingml/2006/main">
+            <a:r>
+              <a:t/>
+            </a:r>
+          </a:p>
+          <a:p xmlns:a="http://schemas.openxmlformats.org/drawingml/2006/main">
+            <a:r>
+              <a:t>【过渡衔接】下一页把复核方法转成 Harness 设计准则，重点看 Coverage、Mandatory 与 FailClosed 三个条件。</a:t>
+            </a:r>
+          </a:p>
+          <a:p xmlns:a="http://schemas.openxmlformats.org/drawingml/2006/main">
+            <a:r>
+              <a:t/>
+            </a:r>
+          </a:p>
+          <a:p xmlns:a="http://schemas.openxmlformats.org/drawingml/2006/main">
+            <a:r>
               <a:t>[Sources]</a:t>
             </a:r>
           </a:p>
           <a:p xmlns:a="http://schemas.openxmlformats.org/drawingml/2006/main">
             <a:r>
-              <a:t>- D:\FDU\科研环节\harness\reports\20_五仓库指令遵从性逐机制代码片段证据.md（第 8–9 节）</a:t>
-            </a:r>
-          </a:p>
-          <a:p xmlns:a="http://schemas.openxmlformats.org/drawingml/2006/main">
-            <a:r>
-              <a:t>- D:\FDU\科研环节\harness\reports\19_五仓库指令遵从性形式化分类与代码证据.md（已同步修正的机制条目）</a:t>
+              <a:t>- reports/18_五仓库指令遵从性静态分析实验记录.md（证据核验流程、测试语义）</a:t>
+            </a:r>
+          </a:p>
+          <a:p xmlns:a="http://schemas.openxmlformats.org/drawingml/2006/main">
+            <a:r>
+              <a:t>- reports/20_五仓库指令遵从性逐机制代码片段证据.md（35 个机制、82 个片段、证据卡结构）</a:t>
             </a:r>
           </a:p>
         </p:txBody>
@@ -633,7 +698,7 @@
           <a:lstStyle xmlns:a="http://schemas.openxmlformats.org/drawingml/2006/main"/>
           <a:p xmlns:a="http://schemas.openxmlformats.org/drawingml/2006/main">
             <a:r>
-              <a:t>这给我们的 Harness 设计一个明确的评价框架。第一，Coverage 要问目标 sink 是否都被覆盖，而不是工具是否出现在 schema 中；第二，Mandatory 要检查直接 API、外部 provider、插件、序列化恢复等旁路；第三，FailClosed 要检查配置缺失、解析异常、网络失败和恢复失败时是否拒绝。只有三者同时满足，才能把局部机制描述为强保证。后续测试不应只验证 happy path，而应主动删除 gate、切换 provider、破坏配置并触发失败分支。</a:t>
+              <a:t>【开场定位】本页将调研结论转化为 Harness 的评价框架。判断一个机制是否能提供强保证，需要同时回答三个问题：目标副作用是否被覆盖，控制是否成为必经路径，失败时是否保持关闭。</a:t>
             </a:r>
           </a:p>
           <a:p xmlns:a="http://schemas.openxmlformats.org/drawingml/2006/main">
@@ -643,17 +708,52 @@
           </a:p>
           <a:p xmlns:a="http://schemas.openxmlformats.org/drawingml/2006/main">
             <a:r>
+              <a:t>【页面解读】Coverage 要从 sink 清单出发，枚举 shell、文件、浏览器、网络、MCP、provider、插件与后台进程，再检查每个入口是否由同一策略覆盖。Mandatory 要寻找直接 API、外部服务、序列化恢复、自定义工具和模式切换等旁路；模型看不到某工具，并不代表执行器不能被其他路径调用。FailClosed 要主动触发配置缺失、解析异常、审批服务失联、工作区创建失败和恢复失败，观察系统是否拒绝、等待、降级或继续。三者可以写成 Guarantee(g)=Coverage(g)∧Mandatory(g)∧FailClosed(g)。任何一项缺失，都应把结论收窄到具体路径。</a:t>
+            </a:r>
+          </a:p>
+          <a:p xmlns:a="http://schemas.openxmlformats.org/drawingml/2006/main">
+            <a:r>
+              <a:t/>
+            </a:r>
+          </a:p>
+          <a:p xmlns:a="http://schemas.openxmlformats.org/drawingml/2006/main">
+            <a:r>
+              <a:t>【证据边界】这个公式是工程审计准则，用来组织可证伪问题；它本身不构成运行时证明。实际验证仍需要 sink 清单、故障注入、旁路测试、审计事件和可重复环境。对于外部 provider，还需要跨组件追踪请求与执行结果。</a:t>
+            </a:r>
+          </a:p>
+          <a:p xmlns:a="http://schemas.openxmlformats.org/drawingml/2006/main">
+            <a:r>
+              <a:t/>
+            </a:r>
+          </a:p>
+          <a:p xmlns:a="http://schemas.openxmlformats.org/drawingml/2006/main">
+            <a:r>
+              <a:t>【过渡衔接】下一页给出可执行的下一步：把当前静态证据升级为围绕真实副作用的动态实验矩阵。</a:t>
+            </a:r>
+          </a:p>
+          <a:p xmlns:a="http://schemas.openxmlformats.org/drawingml/2006/main">
+            <a:r>
+              <a:t/>
+            </a:r>
+          </a:p>
+          <a:p xmlns:a="http://schemas.openxmlformats.org/drawingml/2006/main">
+            <a:r>
               <a:t>[Sources]</a:t>
             </a:r>
           </a:p>
           <a:p xmlns:a="http://schemas.openxmlformats.org/drawingml/2006/main">
             <a:r>
-              <a:t>- D:\FDU\科研环节\harness\reports\19_五仓库指令遵从性形式化分类与代码证据.md（第 7.3 节、第 8 节 RQ3）</a:t>
-            </a:r>
-          </a:p>
-          <a:p xmlns:a="http://schemas.openxmlformats.org/drawingml/2006/main">
-            <a:r>
-              <a:t>- D:\FDU\科研环节\harness\reports\17_五仓库指令遵从性静态分析计划.md（阶段 E 与验收标准）</a:t>
+              <a:t>- reports/17_五仓库指令遵从性静态分析计划.md（阶段 E、验收标准）</a:t>
+            </a:r>
+          </a:p>
+          <a:p xmlns:a="http://schemas.openxmlformats.org/drawingml/2006/main">
+            <a:r>
+              <a:t>- reports/19_五仓库指令遵从性形式化分类与代码证据.md（7.3、RQ3）</a:t>
+            </a:r>
+          </a:p>
+          <a:p xmlns:a="http://schemas.openxmlformats.org/drawingml/2006/main">
+            <a:r>
+              <a:t>- reports/20_五仓库指令遵从性逐机制代码片段证据.md（旁路与证据边界）</a:t>
             </a:r>
           </a:p>
         </p:txBody>
@@ -723,7 +823,7 @@
           <a:lstStyle xmlns:a="http://schemas.openxmlformats.org/drawingml/2006/main"/>
           <a:p xmlns:a="http://schemas.openxmlformats.org/drawingml/2006/main">
             <a:r>
-              <a:t>下一阶段应把静态发现转成可执行反例。第一组实验系统切换默认值、审批回调、provider、序列化和隔离降级，验证机制是否按源码预期失效；第二组让同一用户意图通过不同 sink 执行，检查控制是否跨入口一致；第三组针对仓库边界做集成审计，尤其是 OpenHands 的 SDK/server 与 Cline 外部 provider。组会讨论可以围绕优先顺序展开：先验证最可能产生高危旁路的 L5/L6，还是先建立覆盖全部五仓的统一最小基准。</a:t>
+              <a:t>【开场定位】最后一页把研究收束为下一阶段的实验计划。当前成果已经回答“固定提交中有哪些控制尝试、它们在哪个阶段生效、支配什么、如何失效”，下一步需要验证这些静态关系在可运行系统中是否保持。</a:t>
             </a:r>
           </a:p>
           <a:p xmlns:a="http://schemas.openxmlformats.org/drawingml/2006/main">
@@ -733,22 +833,57 @@
           </a:p>
           <a:p xmlns:a="http://schemas.openxmlformats.org/drawingml/2006/main">
             <a:r>
+              <a:t>【页面解读】第一项工作是建立副作用 sink inventory，把文件写入、命令执行、浏览器导航、网络请求、MCP、provider、插件和后台进程列成统一清单。第二项是设计 bypass matrix：对每个机制切换默认开关、直接调用 API、改变 provider、破坏序列化、注入审批异常、触发 shared 降级，并记录是否仍能到达 sink。第三项是加入 instruction-conflict suite，构造系统、用户、工具返回和环境规则之间的冲突，观察裁决主体与优先级。第四项是做动态追踪，在 gate、sink 与恢复节点记录结构化事件，形成可重复的 E3 证据。最终评价单位应是“副作用入口与控制关系”，并持续保留固定版本和实验配置。</a:t>
+            </a:r>
+          </a:p>
+          <a:p xmlns:a="http://schemas.openxmlformats.org/drawingml/2006/main">
+            <a:r>
+              <a:t/>
+            </a:r>
+          </a:p>
+          <a:p xmlns:a="http://schemas.openxmlformats.org/drawingml/2006/main">
+            <a:r>
+              <a:t>【证据边界】本轮结论限定在五个固定提交和已审计代码路径。我们能够确认大量提示、约束、局部 gate、恢复和审计机制；当前证据仍不足以支持“所有外部副作用都必须经过统一、不可绕过、fail-closed 的指令一致性裁决”这一全称命题。</a:t>
+            </a:r>
+          </a:p>
+          <a:p xmlns:a="http://schemas.openxmlformats.org/drawingml/2006/main">
+            <a:r>
+              <a:t/>
+            </a:r>
+          </a:p>
+          <a:p xmlns:a="http://schemas.openxmlformats.org/drawingml/2006/main">
+            <a:r>
+              <a:t>【收束】组会讨论可以围绕一个问题展开：若要把现有局部控制组合成统一 Harness，哪些 sink 必须先纳入，哪些故障应默认拒绝，哪些外部边界需要联合验证。</a:t>
+            </a:r>
+          </a:p>
+          <a:p xmlns:a="http://schemas.openxmlformats.org/drawingml/2006/main">
+            <a:r>
+              <a:t/>
+            </a:r>
+          </a:p>
+          <a:p xmlns:a="http://schemas.openxmlformats.org/drawingml/2006/main">
+            <a:r>
               <a:t>[Sources]</a:t>
             </a:r>
           </a:p>
           <a:p xmlns:a="http://schemas.openxmlformats.org/drawingml/2006/main">
             <a:r>
-              <a:t>- D:\FDU\科研环节\harness\reports\17_五仓库指令遵从性静态分析计划.md（第 6–8 节）</a:t>
-            </a:r>
-          </a:p>
-          <a:p xmlns:a="http://schemas.openxmlformats.org/drawingml/2006/main">
-            <a:r>
-              <a:t>- D:\FDU\科研环节\harness\reports\18_五仓库指令遵从性静态分析实验记录.md（第 7–8 节）</a:t>
-            </a:r>
-          </a:p>
-          <a:p xmlns:a="http://schemas.openxmlformats.org/drawingml/2006/main">
-            <a:r>
-              <a:t>- D:\FDU\科研环节\harness\reports\20_五仓库指令遵从性逐机制代码片段证据.md（第 8 节证据缺口）</a:t>
+              <a:t>- reports/17_五仓库指令遵从性静态分析计划.md（动态实验方向）</a:t>
+            </a:r>
+          </a:p>
+          <a:p xmlns:a="http://schemas.openxmlformats.org/drawingml/2006/main">
+            <a:r>
+              <a:t>- reports/18_五仓库指令遵从性静态分析实验记录.md（实验限制与复现信息）</a:t>
+            </a:r>
+          </a:p>
+          <a:p xmlns:a="http://schemas.openxmlformats.org/drawingml/2006/main">
+            <a:r>
+              <a:t>- reports/19_五仓库指令遵从性形式化分类与代码证据.md（8–9 节）</a:t>
+            </a:r>
+          </a:p>
+          <a:p xmlns:a="http://schemas.openxmlformats.org/drawingml/2006/main">
+            <a:r>
+              <a:t>- reports/20_五仓库指令遵从性逐机制代码片段证据.md（8–9 节）</a:t>
             </a:r>
           </a:p>
         </p:txBody>
@@ -818,7 +953,7 @@
           <a:lstStyle xmlns:a="http://schemas.openxmlformats.org/drawingml/2006/main"/>
           <a:p xmlns:a="http://schemas.openxmlformats.org/drawingml/2006/main">
             <a:r>
-              <a:t>这一页定义研究单位。我们没有使用用户给出的热度数字做质量排序，因为 star 数与指令遵从没有可证明关系。分析对象是固定提交中的控制机制：它在何处进入调用链、做什么裁决、默认是否启用、失败时放行还是拒绝、以及有没有绕过入口。这里的“支配执行”是关键——如果一个 guard 只改变模型看见的工具列表，但真实执行器仍接受直接调用，它只能算候选空间约束，不能算完整授权。</a:t>
+              <a:t>【开场定位】本页把比较单位从“整个项目”转成一个可检查的控制关系：当 Agent 即将产生外部副作用时，哪段代码、哪个主体、在什么阶段拥有允许、拒绝、询问、变换或停止的裁决权。这样可以把“项目具有安全机制”改写成可回溯的代码问题。</a:t>
             </a:r>
           </a:p>
           <a:p xmlns:a="http://schemas.openxmlformats.org/drawingml/2006/main">
@@ -828,22 +963,52 @@
           </a:p>
           <a:p xmlns:a="http://schemas.openxmlformats.org/drawingml/2006/main">
             <a:r>
+              <a:t>【页面解读】第一组问题看覆盖面：控制是否抵达真实 sink，例如代码执行、文件写入、浏览器导航、MCP 或 provider 调用。第二组问题看失败语义：配置缺失、规则未命中、解析异常、网络失败、序列化恢复时，系统默认放行、拒绝、降级还是等待人工处理。第三组问题看证据等级：实现路径属于 E1，仓库测试源码中的可达断言属于 E2，独立动态复现与生产观测需要更高等级。页面上的 5 个固定快照、35 个机制与 L0–L8 生命周期编码构成后续比较的共同坐标系。</a:t>
+            </a:r>
+          </a:p>
+          <a:p xmlns:a="http://schemas.openxmlformats.org/drawingml/2006/main">
+            <a:r>
+              <a:t/>
+            </a:r>
+          </a:p>
+          <a:p xmlns:a="http://schemas.openxmlformats.org/drawingml/2006/main">
+            <a:r>
+              <a:t>【证据边界】关键词、模块名称和 UI 文案都不能单独证明执行支配。如果某个 guard 只改变模型可见工具，执行器仍接受直接 API 调用，那么它最多约束候选空间。只有当具体 sink 前存在必经裁决，并且失败分支保持关闭，才可以讨论限定路径上的局部强制。</a:t>
+            </a:r>
+          </a:p>
+          <a:p xmlns:a="http://schemas.openxmlformats.org/drawingml/2006/main">
+            <a:r>
+              <a:t/>
+            </a:r>
+          </a:p>
+          <a:p xmlns:a="http://schemas.openxmlformats.org/drawingml/2006/main">
+            <a:r>
+              <a:t>【过渡衔接】确定问题后，下一页说明我们如何从大规模关键词召回收敛到少量可验证机制，并把每条结论连接到调用链和代码证据。</a:t>
+            </a:r>
+          </a:p>
+          <a:p xmlns:a="http://schemas.openxmlformats.org/drawingml/2006/main">
+            <a:r>
+              <a:t/>
+            </a:r>
+          </a:p>
+          <a:p xmlns:a="http://schemas.openxmlformats.org/drawingml/2006/main">
+            <a:r>
               <a:t>[Sources]</a:t>
             </a:r>
           </a:p>
           <a:p xmlns:a="http://schemas.openxmlformats.org/drawingml/2006/main">
             <a:r>
-              <a:t>- D:\FDU\科研环节\harness\reports\17_五仓库指令遵从性静态分析计划.md（第 2–4 节）</a:t>
-            </a:r>
-          </a:p>
-          <a:p xmlns:a="http://schemas.openxmlformats.org/drawingml/2006/main">
-            <a:r>
-              <a:t>- D:\FDU\科研环节\harness\reports\18_五仓库指令遵从性静态分析实验记录.md（第 1 节、第 8 节）</a:t>
-            </a:r>
-          </a:p>
-          <a:p xmlns:a="http://schemas.openxmlformats.org/drawingml/2006/main">
-            <a:r>
-              <a:t>- D:\FDU\科研环节\harness\reports\19_五仓库指令遵从性形式化分类与代码证据.md（第 7.3 节）</a:t>
+              <a:t>- reports/17_五仓库指令遵从性静态分析计划.md（研究问题、操作性定义）</a:t>
+            </a:r>
+          </a:p>
+          <a:p xmlns:a="http://schemas.openxmlformats.org/drawingml/2006/main">
+            <a:r>
+              <a:t>- reports/18_五仓库指令遵从性静态分析实验记录.md（版本固定、扫描范围）</a:t>
+            </a:r>
+          </a:p>
+          <a:p xmlns:a="http://schemas.openxmlformats.org/drawingml/2006/main">
+            <a:r>
+              <a:t>- reports/19_五仓库指令遵从性形式化分类与代码证据.md（结论口径）</a:t>
             </a:r>
           </a:p>
         </p:txBody>
@@ -913,7 +1078,7 @@
           <a:lstStyle xmlns:a="http://schemas.openxmlformats.org/drawingml/2006/main"/>
           <a:p xmlns:a="http://schemas.openxmlformats.org/drawingml/2006/main">
             <a:r>
-              <a:t>方法上先固定每个仓库的 HEAD，再用 Instruction、ToolApproval、Validation、Execution、RecoveryAudit 五组查询做候选召回。关键词只能提高召回率，不能直接形成结论。真正的纳入标准是双向追踪：从候选代码向前找到调用者和决定性分支，再从文件、终端、浏览器、网络等副作用入口向后检查是否必经该控制。最后统一记录默认值、异常语义、旁路和测试断言。E2 只表示仓库作者写了到达该机制的断言，本轮没有把未执行测试描述成“通过”。</a:t>
+              <a:t>【开场定位】这一页解释证据是怎样产生的。核心原则是“关键词负责发现候选，调用链负责确认作用”。我们先固定五个仓库的提交，再用同一组查询族扫描受版本控制文本，从而保证不同项目的召回口径一致。</a:t>
             </a:r>
           </a:p>
           <a:p xmlns:a="http://schemas.openxmlformats.org/drawingml/2006/main">
@@ -923,17 +1088,52 @@
           </a:p>
           <a:p xmlns:a="http://schemas.openxmlformats.org/drawingml/2006/main">
             <a:r>
+              <a:t>【页面解读】流程分为五步。第一步记录 commit、语言和文件范围；第二步使用 Instruction、ToolApproval、Validation、Execution、RecoveryAudit 五族词表召回候选；第三步从实现入口向前追踪调用者、默认配置和决定性分支；第四步从 shell、文件、浏览器、MCP 等真实副作用 sink 反向检查是否存在必经 gate；第五步把机制映射到测试源码中的断言，并统一登记生命周期、受控对象、决策主体、失败语义、旁路和证据等级。实验记录显示，原始命中会混入文档、类型定义、遥测、示例和测试夹具，因此每个纳入项都必须完成双向追踪。</a:t>
+            </a:r>
+          </a:p>
+          <a:p xmlns:a="http://schemas.openxmlformats.org/drawingml/2006/main">
+            <a:r>
+              <a:t/>
+            </a:r>
+          </a:p>
+          <a:p xmlns:a="http://schemas.openxmlformats.org/drawingml/2006/main">
+            <a:r>
+              <a:t>【证据边界】浅克隆适合固定工作树审计，无法支持历史演化结论。测试文件提供的是静态可达性和断言语义，不能自动升级为本地运行成功。外部 SDK 或 server 若不在仓库快照内，只能标记为边界，不能填补为已验证实现。</a:t>
+            </a:r>
+          </a:p>
+          <a:p xmlns:a="http://schemas.openxmlformats.org/drawingml/2006/main">
+            <a:r>
+              <a:t/>
+            </a:r>
+          </a:p>
+          <a:p xmlns:a="http://schemas.openxmlformats.org/drawingml/2006/main">
+            <a:r>
+              <a:t>【过渡衔接】完成筛选后，35 个机制可以压缩成一条分层控制链。下一页先给出跨仓库的核心发现，再在后续页面逐层展开。</a:t>
+            </a:r>
+          </a:p>
+          <a:p xmlns:a="http://schemas.openxmlformats.org/drawingml/2006/main">
+            <a:r>
+              <a:t/>
+            </a:r>
+          </a:p>
+          <a:p xmlns:a="http://schemas.openxmlformats.org/drawingml/2006/main">
+            <a:r>
               <a:t>[Sources]</a:t>
             </a:r>
           </a:p>
           <a:p xmlns:a="http://schemas.openxmlformats.org/drawingml/2006/main">
             <a:r>
-              <a:t>- D:\FDU\科研环节\harness\reports\17_五仓库指令遵从性静态分析计划.md（第 5–7 节）</a:t>
-            </a:r>
-          </a:p>
-          <a:p xmlns:a="http://schemas.openxmlformats.org/drawingml/2006/main">
-            <a:r>
-              <a:t>- D:\FDU\科研环节\harness\reports\18_五仓库指令遵从性静态分析实验记录.md（第 3–6 节）</a:t>
+              <a:t>- reports/17_五仓库指令遵从性静态分析计划.md（静态分析协议、验收标准）</a:t>
+            </a:r>
+          </a:p>
+          <a:p xmlns:a="http://schemas.openxmlformats.org/drawingml/2006/main">
+            <a:r>
+              <a:t>- reports/18_五仓库指令遵从性静态分析实验记录.md（查询族、双向追踪、测试语义）</a:t>
+            </a:r>
+          </a:p>
+          <a:p xmlns:a="http://schemas.openxmlformats.org/drawingml/2006/main">
+            <a:r>
+              <a:t>- reports/20_五仓库指令遵从性逐机制代码片段证据.md（逐机制证据结构）</a:t>
             </a:r>
           </a:p>
         </p:txBody>
@@ -1003,7 +1203,7 @@
           <a:lstStyle xmlns:a="http://schemas.openxmlformats.org/drawingml/2006/main"/>
           <a:p xmlns:a="http://schemas.openxmlformats.org/drawingml/2006/main">
             <a:r>
-              <a:t>五个项目都不是靠一个统一的“指令遵从模块”工作，而是把控制分散在多层。System prompt、rules、skills 主要改变模型的生成倾向；schema、registry 和 tool preset 缩小候选空间；审批回调、导航域检查、文件 containment 才可能在限定入口形成执行前阻断；termination、judge、reporter 与 lint rollback 通常只影响后续步骤或恢复。汇报后续的比较都会沿用这四层，避免把提示、验证、授权和审计混成同一种保证。</a:t>
+              <a:t>【开场定位】本页给出最重要的跨仓结论：指令遵从相关控制分散在一条多层链路上，机制与真实副作用的距离越近，潜在保证通常越强；最终强度仍取决于覆盖范围、是否必经以及失败时是否关闭。</a:t>
             </a:r>
           </a:p>
           <a:p xmlns:a="http://schemas.openxmlformats.org/drawingml/2006/main">
@@ -1013,17 +1213,52 @@
           </a:p>
           <a:p xmlns:a="http://schemas.openxmlformats.org/drawingml/2006/main">
             <a:r>
+              <a:t>【页面解读】第一层是提示诱导，system prompt、rules、skills 和 SOP 提高规则可见性，主要改变模型生成概率。第二层是候选约束，schema、registry、tool preset 和参数模型缩小可表达或可选择的动作集合。第三层是局部执行 gate，例如批准回调、导航域策略、文件 containment，在限定入口前给出 allow、deny 或 ask 决定。第四层是后置恢复与观测，包括 termination、judge、reporter、replay ledger 和 lint rollback，它们影响后续步骤、恢复或审计。形式化上可对应 INDUCE、CONSTRAIN、ENFORCE、DETECT/RECOVER/AUDIT。</a:t>
+            </a:r>
+          </a:p>
+          <a:p xmlns:a="http://schemas.openxmlformats.org/drawingml/2006/main">
+            <a:r>
+              <a:t/>
+            </a:r>
+          </a:p>
+          <a:p xmlns:a="http://schemas.openxmlformats.org/drawingml/2006/main">
+            <a:r>
+              <a:t>【证据边界】提示层无法保证每次生成都符合意图；schema 保证的是形状或枚举范围，不等同于自然语言授权；执行 gate 必须绑定具体 sink、配置和错误分支；后置机制获得了更多结果信息，但某些副作用此时已经发生。报告因此使用“限定路径上的局部保证”，并拒绝把某个单点控制扩展成项目级全局结论。</a:t>
+            </a:r>
+          </a:p>
+          <a:p xmlns:a="http://schemas.openxmlformats.org/drawingml/2006/main">
+            <a:r>
+              <a:t/>
+            </a:r>
+          </a:p>
+          <a:p xmlns:a="http://schemas.openxmlformats.org/drawingml/2006/main">
+            <a:r>
+              <a:t>【过渡衔接】下一页把这四层放回 L0–L8 时间轴，观察控制究竟在运行的哪个阶段生效，以及为何 L5–L6 尤其关键。</a:t>
+            </a:r>
+          </a:p>
+          <a:p xmlns:a="http://schemas.openxmlformats.org/drawingml/2006/main">
+            <a:r>
+              <a:t/>
+            </a:r>
+          </a:p>
+          <a:p xmlns:a="http://schemas.openxmlformats.org/drawingml/2006/main">
+            <a:r>
               <a:t>[Sources]</a:t>
             </a:r>
           </a:p>
           <a:p xmlns:a="http://schemas.openxmlformats.org/drawingml/2006/main">
             <a:r>
-              <a:t>- D:\FDU\科研环节\harness\reports\19_五仓库指令遵从性形式化分类与代码证据.md（第 7–8 节）</a:t>
-            </a:r>
-          </a:p>
-          <a:p xmlns:a="http://schemas.openxmlformats.org/drawingml/2006/main">
-            <a:r>
-              <a:t>- D:\FDU\科研环节\harness\reports\20_五仓库指令遵从性逐机制代码片段证据.md（第 9 节）</a:t>
+              <a:t>- reports/17_五仓库指令遵从性静态分析计划.md（形式化框架）</a:t>
+            </a:r>
+          </a:p>
+          <a:p xmlns:a="http://schemas.openxmlformats.org/drawingml/2006/main">
+            <a:r>
+              <a:t>- reports/19_五仓库指令遵从性形式化分类与代码证据.md（作用方式与跨仓结论）</a:t>
+            </a:r>
+          </a:p>
+          <a:p xmlns:a="http://schemas.openxmlformats.org/drawingml/2006/main">
+            <a:r>
+              <a:t>- reports/20_五仓库指令遵从性逐机制代码片段证据.md（逐机制核验）</a:t>
             </a:r>
           </a:p>
         </p:txBody>
@@ -1093,7 +1328,7 @@
           <a:lstStyle xmlns:a="http://schemas.openxmlformats.org/drawingml/2006/main"/>
           <a:p xmlns:a="http://schemas.openxmlformats.org/drawingml/2006/main">
             <a:r>
-              <a:t>生命周期编码从 L0 配置开始，一直到 L8 完成与审计。五个仓库在 L1 指令上下文、L3 生成和 L4 动作解析上普遍都有机制；真正拉开保证强度的是 L5 授权和 L6 执行隔离。这里要强调时序：执行前检查可以阻止副作用，但往往缺少真实状态；执行后的 judge、lint、timeout 能看到更多结果，却只能告警、停止后续动作或尽力回滚。研究上不能因为一个机制位于 L7/L8，就把它表述为执行前遵从保证。</a:t>
+              <a:t>【开场定位】这一页把控制链放到 Agent 的运行时间轴上。L0–L8 是统一编码，用来比较不同仓库中控制出现的位置、受控对象、跨步状态，以及它离真实副作用还有多远。</a:t>
             </a:r>
           </a:p>
           <a:p xmlns:a="http://schemas.openxmlformats.org/drawingml/2006/main">
@@ -1103,17 +1338,52 @@
           </a:p>
           <a:p xmlns:a="http://schemas.openxmlformats.org/drawingml/2006/main">
             <a:r>
+              <a:t>【页面解读】L0 装载配置、system prompt、规则和运行模式；L1 摄取系统、用户和环境消息；L2 整理上下文、记忆与优先级；L3 生成计划或结构化中间产物；L4 选择工具并检查名称、参数、路径或命令；L5 在执行前处理审批、确认和风险裁决；L6 落实容器、工作目录、浏览器域、文件路径、网络与进程边界；L7 检查结果、完成条件和评审结论；L8 负责重试、重规划、回滚、终止与审计。五个仓库在 L0–L4 普遍有实现，差异更集中在 L5 授权和 L6 资源隔离。</a:t>
+            </a:r>
+          </a:p>
+          <a:p xmlns:a="http://schemas.openxmlformats.org/drawingml/2006/main">
+            <a:r>
+              <a:t/>
+            </a:r>
+          </a:p>
+          <a:p xmlns:a="http://schemas.openxmlformats.org/drawingml/2006/main">
+            <a:r>
+              <a:t>【证据边界】阶段靠后不自动等于保证更强。L5 若没有覆盖所有执行入口，旁路仍然存在；L6 若在失败后退回 shared，或者只设置工作目录而缺少 OS 级边界，隔离语义会减弱；L7–L8 即使准确发现问题，也可能只能停止后续轨迹。静态报告因此同时记录 sink、默认值和故障分支。</a:t>
+            </a:r>
+          </a:p>
+          <a:p xmlns:a="http://schemas.openxmlformats.org/drawingml/2006/main">
+            <a:r>
+              <a:t/>
+            </a:r>
+          </a:p>
+          <a:p xmlns:a="http://schemas.openxmlformats.org/drawingml/2006/main">
+            <a:r>
+              <a:t>【过渡衔接】时间轴回答“何时生效”。下一页进一步回答“以什么方式生效”，并把 35 个机制归并为六类便于跨仓比较。</a:t>
+            </a:r>
+          </a:p>
+          <a:p xmlns:a="http://schemas.openxmlformats.org/drawingml/2006/main">
+            <a:r>
+              <a:t/>
+            </a:r>
+          </a:p>
+          <a:p xmlns:a="http://schemas.openxmlformats.org/drawingml/2006/main">
+            <a:r>
               <a:t>[Sources]</a:t>
             </a:r>
           </a:p>
           <a:p xmlns:a="http://schemas.openxmlformats.org/drawingml/2006/main">
             <a:r>
-              <a:t>- D:\FDU\科研环节\harness\reports\17_五仓库指令遵从性静态分析计划.md（第 3.1 节）</a:t>
-            </a:r>
-          </a:p>
-          <a:p xmlns:a="http://schemas.openxmlformats.org/drawingml/2006/main">
-            <a:r>
-              <a:t>- D:\FDU\科研环节\harness\reports\19_五仓库指令遵从性形式化分类与代码证据.md（第 7.1 节、第 8 节 RQ2）</a:t>
+              <a:t>- reports/17_五仓库指令遵从性静态分析计划.md（生命周期编码）</a:t>
+            </a:r>
+          </a:p>
+          <a:p xmlns:a="http://schemas.openxmlformats.org/drawingml/2006/main">
+            <a:r>
+              <a:t>- reports/19_五仓库指令遵从性形式化分类与代码证据.md（生命周期覆盖、RQ2）</a:t>
+            </a:r>
+          </a:p>
+          <a:p xmlns:a="http://schemas.openxmlformats.org/drawingml/2006/main">
+            <a:r>
+              <a:t>- reports/20_五仓库指令遵从性逐机制代码片段证据.md（各仓机制阶段）</a:t>
             </a:r>
           </a:p>
         </p:txBody>
@@ -1183,7 +1453,7 @@
           <a:lstStyle xmlns:a="http://schemas.openxmlformats.org/drawingml/2006/main"/>
           <a:p xmlns:a="http://schemas.openxmlformats.org/drawingml/2006/main">
             <a:r>
-              <a:t>六类机制按作用方式而不是项目名称划分。前三类帮助模型理解规则并生成可解析动作；第四、第五类才有机会形成执行级保证；第六类用于停止、恢复和审计。星号表示这里的 ENFORCE 不是对整个 Agent 的评级，只是在限定 sink、限定配置下成立。例如 browser-use 的导航 watchdog 可以阻止不允许的 URL，但不能自动支配自定义 Python action；AutoGen 的 approval callback 只覆盖 CodeExecutorAgent 的特定路径。</a:t>
+              <a:t>【开场定位】本页把 35 个机制按作用方式归并，建立一套跨仓库共同语言。分类名称描述代码在控制链中改变了什么，不用于给项目整体打分。一个仓库通常同时覆盖多类机制，保证强度需要结合具体配置和 sink 判断。</a:t>
             </a:r>
           </a:p>
           <a:p xmlns:a="http://schemas.openxmlformats.org/drawingml/2006/main">
@@ -1193,22 +1463,47 @@
           </a:p>
           <a:p xmlns:a="http://schemas.openxmlformats.org/drawingml/2006/main">
             <a:r>
+              <a:t>【页面解读】第一类是规范注入，包括 system prompt、rules、skills 与 SOP，主要产生 INDUCE 效果。第二类是上下文与路由治理，通过 message filter、speaker、sub-agent 和 memory 控制信息流。第三类是动作空间治理，使用 allow-list、schema、registry、Pydantic 或 JSON 协议约束候选动作。第四类是执行前裁决，包括 approval、confirmation、navigation policy。第五类是资源与副作用边界，包括 sandbox、容器、path、secret、上传下载 containment。第六类是完成、恢复与观测，包括 termination、judge、reporter、rollback 和 replay ledger。前三类集中在输入与候选空间，后三类更多接触执行、状态恢复和审计。</a:t>
+            </a:r>
+          </a:p>
+          <a:p xmlns:a="http://schemas.openxmlformats.org/drawingml/2006/main">
+            <a:r>
+              <a:t/>
+            </a:r>
+          </a:p>
+          <a:p xmlns:a="http://schemas.openxmlformats.org/drawingml/2006/main">
+            <a:r>
+              <a:t>【证据边界】图中 ENFORCE 的星号表示条件成立：目标 sink 被覆盖、调用方无法轻易绕开、解析或审批失败时默认拒绝。browser-use 的导航 watchdog、AutoGen 的 code approval、OpenHands 的确认协议都需要保留各自的仓库边界和配置前提。单个代码片段只能证明局部控制关系，无法推出全局自然语言遵从。</a:t>
+            </a:r>
+          </a:p>
+          <a:p xmlns:a="http://schemas.openxmlformats.org/drawingml/2006/main">
+            <a:r>
+              <a:t/>
+            </a:r>
+          </a:p>
+          <a:p xmlns:a="http://schemas.openxmlformats.org/drawingml/2006/main">
+            <a:r>
+              <a:t>【过渡衔接】下一页把六类机制映射回五个仓库，在同一坐标下对照每个项目最强的静态证据和最重要的限制。</a:t>
+            </a:r>
+          </a:p>
+          <a:p xmlns:a="http://schemas.openxmlformats.org/drawingml/2006/main">
+            <a:r>
+              <a:t/>
+            </a:r>
+          </a:p>
+          <a:p xmlns:a="http://schemas.openxmlformats.org/drawingml/2006/main">
+            <a:r>
               <a:t>[Sources]</a:t>
             </a:r>
           </a:p>
           <a:p xmlns:a="http://schemas.openxmlformats.org/drawingml/2006/main">
             <a:r>
-              <a:t>- D:\FDU\科研环节\harness\reports\19_五仓库指令遵从性形式化分类与代码证据.md（第 8 节 RQ1）</a:t>
-            </a:r>
-          </a:p>
-          <a:p xmlns:a="http://schemas.openxmlformats.org/drawingml/2006/main">
-            <a:r>
-              <a:t>- D:\FDU\科研环节\harness\reports\19_五仓库指令遵从性形式化分类与代码证据.md（第 7.3 节）</a:t>
-            </a:r>
-          </a:p>
-          <a:p xmlns:a="http://schemas.openxmlformats.org/drawingml/2006/main">
-            <a:r>
-              <a:t>- D:\FDU\科研环节\harness\reports\20_五仓库指令遵从性逐机制代码片段证据.md（第 2 节覆盖总表）</a:t>
+              <a:t>- reports/19_五仓库指令遵从性形式化分类与代码证据.md（RQ1、RQ3、完整调解判定）</a:t>
+            </a:r>
+          </a:p>
+          <a:p xmlns:a="http://schemas.openxmlformats.org/drawingml/2006/main">
+            <a:r>
+              <a:t>- reports/20_五仓库指令遵从性逐机制代码片段证据.md（机制覆盖总表）</a:t>
             </a:r>
           </a:p>
         </p:txBody>
@@ -1278,7 +1573,7 @@
           <a:lstStyle xmlns:a="http://schemas.openxmlformats.org/drawingml/2006/main"/>
           <a:p xmlns:a="http://schemas.openxmlformats.org/drawingml/2006/main">
             <a:r>
-              <a:t>这一页不是评分榜，而是把每个项目最强的静态证据和最重要的边界放在一起。AutoGen 强在可组合原语，Cline 的 local AgentTool 路径有最清楚的 policy→approval→execute 链，MetaGPT 强在流程与结构化评审，OpenHands 当前仓库主要证明 Canvas 协议，browser-use 则在自己拥有的浏览器与文件 sink 上做了较多确定性检查。共同限制是：最强性质都附带路径、配置或仓库边界，不能直接外推为全局自然语言遵从。</a:t>
+              <a:t>【开场定位】这一页用于横向比较。比较对象是固定提交中最强的局部控制性质，以及它成立所需的路径、配置和外部边界。页面不表达项目综合排名，也不代表真实部署的安全水平。</a:t>
             </a:r>
           </a:p>
           <a:p xmlns:a="http://schemas.openxmlformats.org/drawingml/2006/main">
@@ -1288,17 +1583,47 @@
           </a:p>
           <a:p xmlns:a="http://schemas.openxmlformats.org/drawingml/2006/main">
             <a:r>
+              <a:t>【页面解读】AutoGen 的特点是可组合原语丰富：Workbench 校验工具与参数，InterventionHandler 可改写或丢弃消息，CodeExecutorAgent 在配置 approval callback 时能在执行前拒绝代码。Cline 的 local AgentTool 主链最清楚，模型输出依次经过 normalize、hook、policy、approval，随后才进入 execute。MetaGPT 擅长需求分解、SOP、结构化产物、review 与 rollback。OpenHands 当前仓库主要证明 Canvas 如何组装 instructions、skills、tools、confirmation 和子会话请求，真实执行位于外部 SDK/server。browser-use 在自有浏览器与文件 sink 上实现较多确定性检查，包括动作参数、导航域、secret、上传下载路径和陈旧页面保护。</a:t>
+            </a:r>
+          </a:p>
+          <a:p xmlns:a="http://schemas.openxmlformats.org/drawingml/2006/main">
+            <a:r>
+              <a:t/>
+            </a:r>
+          </a:p>
+          <a:p xmlns:a="http://schemas.openxmlformats.org/drawingml/2006/main">
+            <a:r>
+              <a:t>【证据边界】AutoGen 的审批需要显式配置；Cline 的 provider 和 MCP 路径不共享完整本地审批链；MetaGPT 缺少覆盖通用副作用的统一授权层；OpenHands 无法在当前仓库内闭合 server-side 保证；browser-use 的自定义 action、远端路径和模型自报完成保留旁路。因此，横向表展示的是控制设计取向与局部证据。</a:t>
+            </a:r>
+          </a:p>
+          <a:p xmlns:a="http://schemas.openxmlformats.org/drawingml/2006/main">
+            <a:r>
+              <a:t/>
+            </a:r>
+          </a:p>
+          <a:p xmlns:a="http://schemas.openxmlformats.org/drawingml/2006/main">
+            <a:r>
+              <a:t>【过渡衔接】下一页从横向地图中抽出三条最接近执行强制的路径，具体说明“局部强制”如何成立、又在哪里停止。</a:t>
+            </a:r>
+          </a:p>
+          <a:p xmlns:a="http://schemas.openxmlformats.org/drawingml/2006/main">
+            <a:r>
+              <a:t/>
+            </a:r>
+          </a:p>
+          <a:p xmlns:a="http://schemas.openxmlformats.org/drawingml/2006/main">
+            <a:r>
               <a:t>[Sources]</a:t>
             </a:r>
           </a:p>
           <a:p xmlns:a="http://schemas.openxmlformats.org/drawingml/2006/main">
             <a:r>
-              <a:t>- D:\FDU\科研环节\harness\reports\19_五仓库指令遵从性形式化分类与代码证据.md（第 7.2 节）</a:t>
-            </a:r>
-          </a:p>
-          <a:p xmlns:a="http://schemas.openxmlformats.org/drawingml/2006/main">
-            <a:r>
-              <a:t>- D:\FDU\科研环节\harness\reports\20_五仓库指令遵从性逐机制代码片段证据.md（第 3–7 节）</a:t>
+              <a:t>- reports/19_五仓库指令遵从性形式化分类与代码证据.md（各仓机制、7.2–7.3）</a:t>
+            </a:r>
+          </a:p>
+          <a:p xmlns:a="http://schemas.openxmlformats.org/drawingml/2006/main">
+            <a:r>
+              <a:t>- reports/20_五仓库指令遵从性逐机制代码片段证据.md（第 3–7 节）</a:t>
             </a:r>
           </a:p>
         </p:txBody>
@@ -1368,7 +1693,7 @@
           <a:lstStyle xmlns:a="http://schemas.openxmlformats.org/drawingml/2006/main"/>
           <a:p xmlns:a="http://schemas.openxmlformats.org/drawingml/2006/main">
             <a:r>
-              <a:t>这里给出三条最接近完整调解的局部链路。AutoGen 在 approval callback 已配置时，拒绝分支位于 execute_code_blocks 之前；Cline 对本地已注册工具，在 policy 要求审批时，无回调、拒绝或回调异常都不会进入 execute；browser-use 在自身导航、上传下载和 managed 文件入口上有确定性检查。它们之所以仍称为局部，是因为直接 executor、provider、自定义 action、远端路径等入口不一定经过同一 gate。</a:t>
+              <a:t>【开场定位】本页聚焦本轮静态证据中最接近“执行前支配”的三类路径。它们都能在某个具体 sink 前改变动作是否发生，但成立范围受工具入口、配置和故障语义约束。</a:t>
             </a:r>
           </a:p>
           <a:p xmlns:a="http://schemas.openxmlformats.org/drawingml/2006/main">
@@ -1378,17 +1703,47 @@
           </a:p>
           <a:p xmlns:a="http://schemas.openxmlformats.org/drawingml/2006/main">
             <a:r>
+              <a:t>【页面解读】第一条是 AutoGen CodeExecutorAgent。调用方提供 approval_func 后，拒绝结果或 callback 异常会阻止代码进入 executor；默认 approval_func 为 None 时源码会自动执行，序列化恢复还会把回调重建为空。第二条是 Cline local AgentTool。policy 禁用、hook skip、审批拒绝、缺少 callback 或审批异常都可能生成 skip reason，从而不进入本地 tool.execute；provider.callTool、MCP wrapper 和 detached process 构成范围外路径。第三条是 browser-use。Action Registry 用 Pydantic 复核动作名和参数，SecurityWatchdog 在导航事件前检查 URL，managed filesystem 对上传、下载与路径做 containment；域/IP 默认配置、自定义 action 与 remote path 会改变覆盖面。</a:t>
+            </a:r>
+          </a:p>
+          <a:p xmlns:a="http://schemas.openxmlformats.org/drawingml/2006/main">
+            <a:r>
+              <a:t/>
+            </a:r>
+          </a:p>
+          <a:p xmlns:a="http://schemas.openxmlformats.org/drawingml/2006/main">
+            <a:r>
+              <a:t>【证据边界】这些路径可以支持“给定配置和指定 sink 上的局部强制”。它们尚未同时满足 AllSideEffects 范围内的 Coverage、Mandatory 与 FailClosed。容器或工作目录主要限制危害半径，也不能单独证明动作符合用户指令。</a:t>
+            </a:r>
+          </a:p>
+          <a:p xmlns:a="http://schemas.openxmlformats.org/drawingml/2006/main">
+            <a:r>
+              <a:t/>
+            </a:r>
+          </a:p>
+          <a:p xmlns:a="http://schemas.openxmlformats.org/drawingml/2006/main">
+            <a:r>
+              <a:t>【过渡衔接】下一页转向反面证据：控制在何种默认、异常、序列化、外部执行或后置检查条件下失去作用。</a:t>
+            </a:r>
+          </a:p>
+          <a:p xmlns:a="http://schemas.openxmlformats.org/drawingml/2006/main">
+            <a:r>
+              <a:t/>
+            </a:r>
+          </a:p>
+          <a:p xmlns:a="http://schemas.openxmlformats.org/drawingml/2006/main">
+            <a:r>
               <a:t>[Sources]</a:t>
             </a:r>
           </a:p>
           <a:p xmlns:a="http://schemas.openxmlformats.org/drawingml/2006/main">
             <a:r>
-              <a:t>- D:\FDU\科研环节\harness\reports\19_五仓库指令遵从性形式化分类与代码证据.md（AG-4、CL-2、BU-3/BU-5 与第 7.3 节）</a:t>
-            </a:r>
-          </a:p>
-          <a:p xmlns:a="http://schemas.openxmlformats.org/drawingml/2006/main">
-            <a:r>
-              <a:t>- D:\FDU\科研环节\harness\reports\20_五仓库指令遵从性逐机制代码片段证据.md（对应逐机制代码片段）</a:t>
+              <a:t>- reports/19_五仓库指令遵从性形式化分类与代码证据.md（AutoGen、Cline、browser-use；完整调解判定）</a:t>
+            </a:r>
+          </a:p>
+          <a:p xmlns:a="http://schemas.openxmlformats.org/drawingml/2006/main">
+            <a:r>
+              <a:t>- reports/20_五仓库指令遵从性逐机制代码片段证据.md（对应代码片段与 sink）</a:t>
             </a:r>
           </a:p>
         </p:txBody>
@@ -1458,7 +1813,7 @@
           <a:lstStyle xmlns:a="http://schemas.openxmlformats.org/drawingml/2006/main"/>
           <a:p xmlns:a="http://schemas.openxmlformats.org/drawingml/2006/main">
             <a:r>
-              <a:t>静态审计最有价值的部分往往不是找到 guard，而是找到它在什么条件下消失。OpenHands 的 confirmation 默认关闭；Cline 未列入 policy 的工具默认可用并自动批准；AutoGen 的审批回调在配置序列化后被恢复为 None；MetaGPT 有评估结果却不一定阻止保存；browser-use 的 judge 只做后置测量；OpenHands 子会话在 worktree 创建失败时会透明降级到 shared。它们分别对应默认、规则缺失、持久化、支配关系、时序和恢复语义六类风险。</a:t>
+              <a:t>【开场定位】静态审计的价值很大一部分来自失效条件分析。找到 guard 只是起点，还要继续检查默认值、未匹配规则、序列化恢复、外部 provider、故障降级与执行后判断，才能知道控制在真实调用链中何时消失。</a:t>
             </a:r>
           </a:p>
           <a:p xmlns:a="http://schemas.openxmlformats.org/drawingml/2006/main">
@@ -1468,17 +1823,47 @@
           </a:p>
           <a:p xmlns:a="http://schemas.openxmlformats.org/drawingml/2006/main">
             <a:r>
+              <a:t>【页面解读】OpenHands 的 confirmation mode 默认关闭，worktree 创建失败会退回 shared，真正 pending action 与执行阻断位于外部 server。Cline 对未列入 policy 的本地工具可自动批准，provider 和通用 MCP 不共享同一 gate，pre-hook 异常多数继续执行。AutoGen 的 code approval 属于可选回调，配置恢复后可能变成 None。MetaGPT 的 evaluation 结果没有稳定支配 save_framework，人工确认使用字符串包含匹配，Terminal 黑名单范围有限。browser-use 的域与 IP 限制默认较宽松，自定义 action 的 domain filter 主要发生在 schema 构造阶段，trace judge 和 done 机制又位于动作之后。</a:t>
+            </a:r>
+          </a:p>
+          <a:p xmlns:a="http://schemas.openxmlformats.org/drawingml/2006/main">
+            <a:r>
+              <a:t/>
+            </a:r>
+          </a:p>
+          <a:p xmlns:a="http://schemas.openxmlformats.org/drawingml/2006/main">
+            <a:r>
+              <a:t>【证据边界】这里列出的都是固定提交中的可见边界，不代表相关团队没有在外部部署补充控制。静态分析只能对仓库内可观察路径负责。旁路也不等于必然产生危害，它说明全局保证所需的完整调解条件尚未由当前代码证据覆盖。</a:t>
+            </a:r>
+          </a:p>
+          <a:p xmlns:a="http://schemas.openxmlformats.org/drawingml/2006/main">
+            <a:r>
+              <a:t/>
+            </a:r>
+          </a:p>
+          <a:p xmlns:a="http://schemas.openxmlformats.org/drawingml/2006/main">
+            <a:r>
+              <a:t>【过渡衔接】下一页说明我们如何把这些边界和正向机制逐一落实到代码片段，确保每个结论都有可复核的证据卡片。</a:t>
+            </a:r>
+          </a:p>
+          <a:p xmlns:a="http://schemas.openxmlformats.org/drawingml/2006/main">
+            <a:r>
+              <a:t/>
+            </a:r>
+          </a:p>
+          <a:p xmlns:a="http://schemas.openxmlformats.org/drawingml/2006/main">
+            <a:r>
               <a:t>[Sources]</a:t>
             </a:r>
           </a:p>
           <a:p xmlns:a="http://schemas.openxmlformats.org/drawingml/2006/main">
             <a:r>
-              <a:t>- D:\FDU\科研环节\harness\reports\19_五仓库指令遵从性形式化分类与代码证据.md（各仓机制小结与第 8 节 RQ3）</a:t>
-            </a:r>
-          </a:p>
-          <a:p xmlns:a="http://schemas.openxmlformats.org/drawingml/2006/main">
-            <a:r>
-              <a:t>- D:\FDU\科研环节\harness\reports\20_五仓库指令遵从性逐机制代码片段证据.md（第 8.3 节修正清单）</a:t>
+              <a:t>- reports/19_五仓库指令遵从性形式化分类与代码证据.md（各仓边界、RQ3）</a:t>
+            </a:r>
+          </a:p>
+          <a:p xmlns:a="http://schemas.openxmlformats.org/drawingml/2006/main">
+            <a:r>
+              <a:t>- reports/20_五仓库指令遵从性逐机制代码片段证据.md（8.3 修正清单与逐机制核验）</a:t>
             </a:r>
           </a:p>
         </p:txBody>
@@ -1546,7 +1931,7 @@
   </p:cSld>
   <p:clrMap bg1="lt1" tx1="dk1" bg2="lt2" tx2="dk2" accent1="accent1" accent2="accent2" accent3="accent3" accent4="accent4" accent5="accent5" accent6="accent6" hlink="hlink" folHlink="folHlink"/>
   <p:sldLayoutIdLst>
-    <p:sldLayoutId xmlns:r="http://schemas.openxmlformats.org/officeDocument/2006/relationships" id="2147483649" r:id="R47e3a815fe8e4350"/>
+    <p:sldLayoutId xmlns:r="http://schemas.openxmlformats.org/officeDocument/2006/relationships" id="2147483649" r:id="R2296bac3ed5243a8"/>
   </p:sldLayoutIdLst>
   <p:txStyles>
     <p:titleStyle>
@@ -3983,7 +4368,7 @@
                   <a:srgbClr val="555555"/>
                 </a:solidFill>
               </a:rPr>
-              <a:t>不是只隐藏模型可见工具</a:t>
+              <a:t>需覆盖真实副作用入口</a:t>
             </a:r>
           </a:p>
         </p:txBody>
@@ -5218,7 +5603,7 @@
                   <a:srgbClr val="FFFFFF"/>
                 </a:solidFill>
               </a:rPr>
-              <a:t>不再只问“有没有 guardrail”</a:t>
+              <a:t>评价焦点：真实副作用</a:t>
             </a:r>
           </a:p>
         </p:txBody>
@@ -5269,7 +5654,7 @@
                   <a:srgbClr val="FFFFFF"/>
                 </a:solidFill>
               </a:rPr>
-              <a:t>而要问：每个副作用由谁、何时、以何种失败语义裁决？</a:t>
+              <a:t>每个副作用由谁、何时、以何种失败语义裁决？</a:t>
             </a:r>
           </a:p>
         </p:txBody>
@@ -5482,7 +5867,7 @@
                   <a:srgbClr val="111111"/>
                 </a:solidFill>
               </a:rPr>
-              <a:t>我们不做项目排名，而是检查控制是否真的支配执行</a:t>
+              <a:t>我们关注控制是否真正支配执行</a:t>
             </a:r>
           </a:p>
         </p:txBody>
@@ -7755,7 +8140,7 @@
                   <a:srgbClr val="111111"/>
                 </a:solidFill>
               </a:rPr>
-              <a:t>核心结论：指令遵从不是一个模块，而是一条控制链</a:t>
+              <a:t>核心结论：指令遵从由多层控制链共同构成</a:t>
             </a:r>
           </a:p>
         </p:txBody>

</xml_diff>